<commit_message>
Sync pptx with the docx's honest Jinda and mobile-app findings
The docx (Chapter 4) already reported these from live testing; the pptx
still showed both as unqualified "DONE". Now consistent: the mobile app
status pill changed from DONE to BUILT (built and reaching the backend,
not yet exercised on a physical device - matches the Objective 12 caveat
in Chapter 4), and the Work Carried Out speaker notes now state Jinda's
real, tested behavior (handles a recognised request, including Shona,
and navigates correctly; falls back to a generic keyword match rather
than reasoning through an open-ended question) if asked to elaborate.

Co-Authored-By: Claude Sonnet 5 <noreply@anthropic.com>
</commit_message>
<xml_diff>
--- a/DOCUMENTATION/PRESENTATIONS/PFUMA_INGCEBO_Progress_Presentation.pptx
+++ b/DOCUMENTATION/PRESENTATIONS/PFUMA_INGCEBO_Progress_Presentation.pptx
@@ -933,7 +933,7 @@
           <a:lstStyle/>
           <a:p>
             <a:r>
-              <a:t>(3 minutes) * Core workflows = marketplace, sale clearance, the valuation certificate, institution ledger, outbreak reporting, the messenger, farmer cooperatives, the health-compliance lifecycle, feed/trading tools, and the natural-language assistant - say this if asked what the pill covers. Be honest and confident: the platform itself is built and demoable locally; the remaining work is the academic write-up, not the software.</a:t>
+              <a:t>(3 minutes) * Core workflows = marketplace, sale clearance, the valuation certificate, institution ledger, outbreak reporting, the messenger, farmer cooperatives, the health-compliance lifecycle, feed/trading tools, and the natural-language assistant - say this if asked what the pill covers. Be honest and confident: the platform itself is built and demoable locally; the remaining work is the academic write-up, not the software. On Jinda specifically, if asked how smart it is: it correctly handles a recognised request, including one typed in Shona, and actually navigates the app - shown live in testing. It does not reason through an open-ended question (tested: asked why a vaccine was overdue, it fell back to a generic keyword match instead of answering). Say this plainly if asked - it is a fixed rule set, not a language model, by design (see Table 3.1), and that tradeoff is the honest answer.</a:t>
             </a:r>
           </a:p>
         </p:txBody>
@@ -21497,7 +21497,7 @@
                 </a:solidFill>
                 <a:latin typeface="Arial"/>
               </a:rPr>
-              <a:t>• The web app and the mobile app are both built, close to feature parity.</a:t>
+              <a:t>• The web app is built and demoed live; the mobile app is built and reaches the same backend, but has not yet been exercised on a physical device.</a:t>
             </a:r>
           </a:p>
           <a:p>
@@ -21809,7 +21809,7 @@
             <a:avLst/>
           </a:prstGeom>
           <a:solidFill>
-            <a:srgbClr val="2FA05A"/>
+            <a:srgbClr val="E58226"/>
           </a:solidFill>
           <a:ln>
             <a:noFill/>
@@ -21841,7 +21841,7 @@
                 </a:solidFill>
                 <a:latin typeface="Arial"/>
               </a:rPr>
-              <a:t>DONE</a:t>
+              <a:t>BUILT</a:t>
             </a:r>
           </a:p>
         </p:txBody>

</xml_diff>

<commit_message>
Sync pptx Background slide with the docx's price-discovery point; ignore Office lock files
Added the same missing point to the pptx that was just added to the
dissertation: a farmer can't find a certified buyer or a credible
independent valuation, only a paper trail gap. New bullet + a fifth
panel box on the Background slide.

Also adds ~$* to .gitignore — Office's transient lock files for an open
docx/pptx/xlsx kept getting staged every time a document was opened for
review this session and had to be manually unstaged before each commit.

Co-Authored-By: Claude Sonnet 5 <noreply@anthropic.com>
</commit_message>
<xml_diff>
--- a/DOCUMENTATION/PRESENTATIONS/PFUMA_INGCEBO_Progress_Presentation.pptx
+++ b/DOCUMENTATION/PRESENTATIONS/PFUMA_INGCEBO_Progress_Presentation.pptx
@@ -22956,6 +22956,22 @@
               <a:t>• Stock theft and ownership disputes have no fast, credible evidence trail, and livestock wealth cannot easily be used as loan collateral without a verifiable record.</a:t>
             </a:r>
           </a:p>
+          <a:p>
+            <a:pPr algn="l">
+              <a:spcAft>
+                <a:spcPts val="900"/>
+              </a:spcAft>
+            </a:pPr>
+            <a:r>
+              <a:rPr sz="1700">
+                <a:solidFill>
+                  <a:srgbClr val="141414"/>
+                </a:solidFill>
+                <a:latin typeface="Arial"/>
+              </a:rPr>
+              <a:t>• A farmer selling an animal has no efficient way to find a certified buyer or a credible independent valuation, so a sale is commonly word of mouth, at whatever price a wandering buyer offers.</a:t>
+            </a:r>
+          </a:p>
         </p:txBody>
       </p:sp>
       <p:sp>
@@ -23257,6 +23273,70 @@
                 <a:latin typeface="Arial"/>
               </a:rPr>
               <a:t>AGAINST</a:t>
+            </a:r>
+          </a:p>
+        </p:txBody>
+      </p:sp>
+      <p:sp>
+        <p:nvSpPr>
+          <p:cNvPr id="10" name="Rounded Rectangle 9"/>
+          <p:cNvSpPr/>
+          <p:nvPr/>
+        </p:nvSpPr>
+        <p:spPr>
+          <a:xfrm>
+            <a:off x="7680960" y="4983480"/>
+            <a:ext cx="2377440" cy="777240"/>
+          </a:xfrm>
+          <a:prstGeom prst="roundRect">
+            <a:avLst/>
+          </a:prstGeom>
+          <a:solidFill>
+            <a:srgbClr val="7D7D7D"/>
+          </a:solidFill>
+          <a:ln>
+            <a:noFill/>
+          </a:ln>
+        </p:spPr>
+        <p:style>
+          <a:lnRef idx="1">
+            <a:schemeClr val="accent1"/>
+          </a:lnRef>
+          <a:fillRef idx="3">
+            <a:schemeClr val="accent1"/>
+          </a:fillRef>
+          <a:effectRef idx="2">
+            <a:schemeClr val="accent1"/>
+          </a:effectRef>
+          <a:fontRef idx="minor">
+            <a:schemeClr val="lt1"/>
+          </a:fontRef>
+        </p:style>
+        <p:txBody>
+          <a:bodyPr rtlCol="0" anchor="ctr" wrap="square"/>
+          <a:lstStyle/>
+          <a:p>
+            <a:pPr algn="ctr"/>
+            <a:r>
+              <a:rPr sz="1200" b="1">
+                <a:solidFill>
+                  <a:srgbClr val="FFFFFF"/>
+                </a:solidFill>
+                <a:latin typeface="Arial"/>
+              </a:rPr>
+              <a:t>NO CERTIFIED BUYER,</a:t>
+            </a:r>
+          </a:p>
+          <a:p>
+            <a:pPr algn="ctr"/>
+            <a:r>
+              <a:rPr sz="1200" b="1">
+                <a:solidFill>
+                  <a:srgbClr val="FFFFFF"/>
+                </a:solidFill>
+                <a:latin typeface="Arial"/>
+              </a:rPr>
+              <a:t>NO CREDIBLE VALUATION</a:t>
             </a:r>
           </a:p>
         </p:txBody>

</xml_diff>

<commit_message>
Fix Main Elements of the Problem slide missing the price-discovery point
The Why bullet and its panel box still only named buyers/banks/police -
the same gap just fixed on Background hadn't propagated here. Now the
Why bullet and the red panel box both cover a selling farmer's inability
to find a certified buyer or a credible valuation too.

Co-Authored-By: Claude Sonnet 5 <noreply@anthropic.com>
</commit_message>
<xml_diff>
--- a/DOCUMENTATION/PRESENTATIONS/PFUMA_INGCEBO_Progress_Presentation.pptx
+++ b/DOCUMENTATION/PRESENTATIONS/PFUMA_INGCEBO_Progress_Presentation.pptx
@@ -23488,7 +23488,7 @@
                 </a:solidFill>
                 <a:latin typeface="Arial"/>
               </a:rPr>
-              <a:t>• Why: this leaves buyers, banks, and police with nothing credible to check before a sale, a loan, or an investigation.</a:t>
+              <a:t>• Why: this leaves buyers, banks, and police with nothing credible to check before a sale, a loan, or an investigation — and leaves a selling farmer with no way to find a certified buyer or a credible valuation either.</a:t>
             </a:r>
           </a:p>
           <a:p>
@@ -23617,7 +23617,7 @@
         <p:spPr>
           <a:xfrm>
             <a:off x="7360920" y="2788920"/>
-            <a:ext cx="2926080" cy="777240"/>
+            <a:ext cx="2926080" cy="868680"/>
           </a:xfrm>
           <a:prstGeom prst="roundRect">
             <a:avLst/>
@@ -23649,7 +23649,7 @@
           <a:p>
             <a:pPr algn="ctr"/>
             <a:r>
-              <a:rPr sz="1200" b="1">
+              <a:rPr sz="1000" b="1">
                 <a:solidFill>
                   <a:srgbClr val="FFFFFF"/>
                 </a:solidFill>
@@ -23661,13 +23661,25 @@
           <a:p>
             <a:pPr algn="ctr"/>
             <a:r>
-              <a:rPr sz="1200" b="1">
+              <a:rPr sz="1000" b="1">
                 <a:solidFill>
                   <a:srgbClr val="FFFFFF"/>
                 </a:solidFill>
                 <a:latin typeface="Arial"/>
               </a:rPr>
-              <a:t>BANKS, OR POLICE</a:t>
+              <a:t>BANKS, POLICE, OR SELLERS</a:t>
+            </a:r>
+          </a:p>
+          <a:p>
+            <a:pPr algn="ctr"/>
+            <a:r>
+              <a:rPr sz="1000" b="1">
+                <a:solidFill>
+                  <a:srgbClr val="FFFFFF"/>
+                </a:solidFill>
+                <a:latin typeface="Arial"/>
+              </a:rPr>
+              <a:t>SEEKING A BUYER</a:t>
             </a:r>
           </a:p>
         </p:txBody>

</xml_diff>